<commit_message>
State the evidence set and the configuration terms in Figure 2
Figure 2 still carried the terms 'Candidate recipe', 'Development
evidence' and 'Aggregated development evidence' that the method text no
longer uses.  The three arrow labels are rebuilt from the author deck: the
down arrow reads Candidate / model design and training hyperparameters, the
up arrow reads Development evidence E_t / (one card per trial), and the
feedback arrow reads Aggregated development evidence E_t / (configuration,
dev score, decision).  The retention label keeps the dev score term, which
Section 3.2 now also defines, and the caption defines the persistent
evidence set and the card contents.
</commit_message>
<xml_diff>
--- a/figures/biocoloop_framework_v3.pptx
+++ b/figures/biocoloop_framework_v3.pptx
@@ -3856,8 +3856,8 @@
         </p:nvSpPr>
         <p:spPr>
           <a:xfrm>
-            <a:off x="3144925" y="1173300"/>
-            <a:ext cx="2675902" cy="266700"/>
+            <a:off x="2850800" y="1116700"/>
+            <a:ext cx="3290000" cy="380000"/>
           </a:xfrm>
           <a:prstGeom prst="rect">
             <a:avLst/>
@@ -3873,6 +3873,9 @@
           <a:lstStyle/>
           <a:p>
             <a:pPr marL="0" indent="0" algn="ctr">
+              <a:lnSpc>
+                <a:spcPct val="100000"/>
+              </a:lnSpc>
               <a:buNone/>
             </a:pPr>
             <a:r>
@@ -3884,13 +3887,27 @@
                 <a:ea typeface="Arial"/>
                 <a:cs typeface="Arial" panose="020B0604020202020204" pitchFamily="34" charset="0"/>
               </a:rPr>
-              <a:t>Aggregated development evidence</a:t>
-            </a:r>
-            <a:endParaRPr sz="1400" i="1">
-              <a:latin typeface="Arial" panose="020B0604020202020204" pitchFamily="34" charset="0"/>
-              <a:ea typeface="Calibri"/>
-              <a:cs typeface="Arial" panose="020B0604020202020204" pitchFamily="34" charset="0"/>
-            </a:endParaRPr>
+              <a:t>Aggregated development evidence ℰₜ</a:t>
+            </a:r>
+          </a:p>
+          <a:p>
+            <a:pPr marL="0" indent="0" algn="ctr">
+              <a:lnSpc>
+                <a:spcPct val="100000"/>
+              </a:lnSpc>
+              <a:buNone/>
+            </a:pPr>
+            <a:r>
+              <a:rPr lang="en-US" sz="950" i="1">
+                <a:solidFill>
+                  <a:srgbClr val="0A51A1"/>
+                </a:solidFill>
+                <a:latin typeface="Arial" panose="020B0604020202020204" pitchFamily="34" charset="0"/>
+                <a:ea typeface="Arial"/>
+                <a:cs typeface="Arial" panose="020B0604020202020204" pitchFamily="34" charset="0"/>
+              </a:rPr>
+              <a:t>(configuration, dev score, decision)</a:t>
+            </a:r>
           </a:p>
         </p:txBody>
       </p:sp>
@@ -3976,8 +3993,8 @@
         </p:nvSpPr>
         <p:spPr>
           <a:xfrm>
-            <a:off x="4393952" y="2752438"/>
-            <a:ext cx="922457" cy="265424"/>
+            <a:off x="3810000" y="2600000"/>
+            <a:ext cx="1498600" cy="444500"/>
           </a:xfrm>
           <a:prstGeom prst="rect">
             <a:avLst/>
@@ -3997,7 +4014,7 @@
               <a:buNone/>
             </a:pPr>
             <a:r>
-              <a:rPr sz="1275">
+              <a:rPr lang="en-US" sz="1000">
                 <a:solidFill>
                   <a:srgbClr val="0A51A1"/>
                 </a:solidFill>
@@ -4007,14 +4024,6 @@
               </a:rPr>
               <a:t>Candidate</a:t>
             </a:r>
-            <a:endParaRPr lang="en-US" sz="1275">
-              <a:solidFill>
-                <a:srgbClr val="0A51A1"/>
-              </a:solidFill>
-              <a:latin typeface="Arial" panose="020B0604020202020204" pitchFamily="34" charset="0"/>
-              <a:ea typeface="Arial"/>
-              <a:cs typeface="Arial" panose="020B0604020202020204" pitchFamily="34" charset="0"/>
-            </a:endParaRPr>
           </a:p>
           <a:p>
             <a:pPr marL="0" indent="0" algn="ctr">
@@ -4024,7 +4033,7 @@
               <a:buNone/>
             </a:pPr>
             <a:r>
-              <a:rPr lang="en-US" sz="1275">
+              <a:rPr lang="en-US" sz="1000">
                 <a:solidFill>
                   <a:srgbClr val="0A51A1"/>
                 </a:solidFill>
@@ -4032,15 +4041,27 @@
                 <a:ea typeface="Arial"/>
                 <a:cs typeface="Arial" panose="020B0604020202020204" pitchFamily="34" charset="0"/>
               </a:rPr>
-              <a:t>design</a:t>
-            </a:r>
-            <a:endParaRPr sz="1420">
-              <a:solidFill>
-                <a:srgbClr val="0A51A1"/>
-              </a:solidFill>
-              <a:latin typeface="Arial" panose="020B0604020202020204" pitchFamily="34" charset="0"/>
-              <a:cs typeface="Arial" panose="020B0604020202020204" pitchFamily="34" charset="0"/>
-            </a:endParaRPr>
+              <a:t>model design and</a:t>
+            </a:r>
+          </a:p>
+          <a:p>
+            <a:pPr marL="0" indent="0" algn="ctr">
+              <a:lnSpc>
+                <a:spcPct val="100000"/>
+              </a:lnSpc>
+              <a:buNone/>
+            </a:pPr>
+            <a:r>
+              <a:rPr lang="en-US" sz="1000">
+                <a:solidFill>
+                  <a:srgbClr val="0A51A1"/>
+                </a:solidFill>
+                <a:latin typeface="Arial" panose="020B0604020202020204" pitchFamily="34" charset="0"/>
+                <a:ea typeface="Arial"/>
+                <a:cs typeface="Arial" panose="020B0604020202020204" pitchFamily="34" charset="0"/>
+              </a:rPr>
+              <a:t>training hyperparameters</a:t>
+            </a:r>
           </a:p>
         </p:txBody>
       </p:sp>
@@ -4060,8 +4081,8 @@
         </p:nvSpPr>
         <p:spPr>
           <a:xfrm>
-            <a:off x="5771504" y="2697068"/>
-            <a:ext cx="1161288" cy="393192"/>
+            <a:off x="5524500" y="2595700"/>
+            <a:ext cx="1206500" cy="596900"/>
           </a:xfrm>
           <a:prstGeom prst="rect">
             <a:avLst/>
@@ -4081,7 +4102,7 @@
               <a:buNone/>
             </a:pPr>
             <a:r>
-              <a:rPr sz="1275">
+              <a:rPr lang="en-US" sz="1275">
                 <a:solidFill>
                   <a:srgbClr val="087A62"/>
                 </a:solidFill>
@@ -4091,13 +4112,6 @@
               </a:rPr>
               <a:t>Development</a:t>
             </a:r>
-            <a:endParaRPr sz="1370">
-              <a:solidFill>
-                <a:srgbClr val="087A62"/>
-              </a:solidFill>
-              <a:latin typeface="Arial" panose="020B0604020202020204" pitchFamily="34" charset="0"/>
-              <a:cs typeface="Arial" panose="020B0604020202020204" pitchFamily="34" charset="0"/>
-            </a:endParaRPr>
           </a:p>
           <a:p>
             <a:pPr marL="0" indent="0" algn="ctr">
@@ -4107,7 +4121,7 @@
               <a:buNone/>
             </a:pPr>
             <a:r>
-              <a:rPr sz="1275">
+              <a:rPr lang="en-US" sz="1275">
                 <a:solidFill>
                   <a:srgbClr val="087A62"/>
                 </a:solidFill>
@@ -4115,15 +4129,27 @@
                 <a:ea typeface="Arial"/>
                 <a:cs typeface="Arial" panose="020B0604020202020204" pitchFamily="34" charset="0"/>
               </a:rPr>
-              <a:t>evidence</a:t>
-            </a:r>
-            <a:endParaRPr sz="1370">
-              <a:solidFill>
-                <a:srgbClr val="087A62"/>
-              </a:solidFill>
-              <a:latin typeface="Arial" panose="020B0604020202020204" pitchFamily="34" charset="0"/>
-              <a:cs typeface="Arial" panose="020B0604020202020204" pitchFamily="34" charset="0"/>
-            </a:endParaRPr>
+              <a:t>evidence ℰₜ</a:t>
+            </a:r>
+          </a:p>
+          <a:p>
+            <a:pPr marL="0" indent="0" algn="ctr">
+              <a:lnSpc>
+                <a:spcPct val="100000"/>
+              </a:lnSpc>
+              <a:buNone/>
+            </a:pPr>
+            <a:r>
+              <a:rPr lang="en-US" sz="950" i="1">
+                <a:solidFill>
+                  <a:srgbClr val="087A62"/>
+                </a:solidFill>
+                <a:latin typeface="Arial" panose="020B0604020202020204" pitchFamily="34" charset="0"/>
+                <a:ea typeface="Arial"/>
+                <a:cs typeface="Arial" panose="020B0604020202020204" pitchFamily="34" charset="0"/>
+              </a:rPr>
+              <a:t>(one card per trial)</a:t>
+            </a:r>
           </a:p>
         </p:txBody>
       </p:sp>

</xml_diff>